<commit_message>
Restructure Demo Day 6 deck to the final 6-section brief + highlights
</commit_message>
<xml_diff>
--- a/marketing/demo-day-6-deck.pptx
+++ b/marketing/demo-day-6-deck.pptx
@@ -4059,7 +4059,7 @@
                 </a:solidFill>
                 <a:latin typeface="Arial"/>
               </a:rPr>
-              <a:t>From silent to spreading the word · quick skill games, real G$ on Celo</a:t>
+              <a:t>Quick skill games. Real G$. Real humans — never bots.</a:t>
             </a:r>
           </a:p>
           <a:p>
@@ -4075,7 +4075,7 @@
                 </a:solidFill>
                 <a:latin typeface="Arial"/>
               </a:rPr>
-              <a:t>Ogazboiz  ·  gamearenahq.xyz  ·  GoodBuilders S4 · Demo Day 6</a:t>
+              <a:t>Ogazboiz  ·  gamearenahq.xyz  ·  GoodBuilders S4  ·  Final Demo Day</a:t>
             </a:r>
           </a:p>
         </p:txBody>
@@ -4151,7 +4151,7 @@
                 </a:solidFill>
                 <a:latin typeface="Arial"/>
               </a:rPr>
-              <a:t>01 · RECAP</a:t>
+              <a:t>01 · WHERE WE STARTED</a:t>
             </a:r>
           </a:p>
         </p:txBody>
@@ -4185,7 +4185,7 @@
                 </a:solidFill>
                 <a:latin typeface="Arial"/>
               </a:rPr>
-              <a:t>We had the engine — we were too quiet</a:t>
+              <a:t>Play-to-earn pays bots, not people</a:t>
             </a:r>
           </a:p>
         </p:txBody>
@@ -4236,7 +4236,7 @@
                 </a:solidFill>
                 <a:latin typeface="Arial"/>
               </a:rPr>
-              <a:t>Events engine shipped: prize pools, duels, auto-payout on-chain</a:t>
+              <a:t>Every reward game gets farmed by scripts and spare wallets — the pool drains to no one real</a:t>
             </a:r>
           </a:p>
           <a:p>
@@ -4264,7 +4264,7 @@
                 </a:solidFill>
                 <a:latin typeface="Arial"/>
               </a:rPr>
-              <a:t>This month: turned it into a growth machine and spread the word</a:t>
+              <a:t>Our bet: gate every game and prize on GoodDollar proof-of-personhood. Zero bots ever paid.</a:t>
             </a:r>
           </a:p>
         </p:txBody>
@@ -4340,7 +4340,7 @@
                 </a:solidFill>
                 <a:latin typeface="Arial"/>
               </a:rPr>
-              <a:t>02 · WHAT WE SHIPPED</a:t>
+              <a:t>02 · WHERE WE ARE NOW</a:t>
             </a:r>
           </a:p>
         </p:txBody>
@@ -4374,7 +4374,7 @@
                 </a:solidFill>
                 <a:latin typeface="Arial"/>
               </a:rPr>
-              <a:t>Turned the engine into a growth machine</a:t>
+              <a:t>Growth, all on-chain</a:t>
             </a:r>
           </a:p>
         </p:txBody>
@@ -4425,7 +4425,7 @@
                 </a:solidFill>
                 <a:latin typeface="Arial"/>
               </a:rPr>
-              <a:t>Tug of War — biggest event yet: 2,000,000 G$, two teams, 7 days</a:t>
+              <a:t>227 — 879 players across the season</a:t>
             </a:r>
           </a:p>
           <a:p>
@@ -4453,7 +4453,7 @@
                 </a:solidFill>
                 <a:latin typeface="Arial"/>
               </a:rPr>
-              <a:t>Verified players rebuilt — recovered our lapsed base to 168 (19%) and climbing</a:t>
+              <a:t>163 verified humans (19%) — rebuilt from a lapsed base</a:t>
             </a:r>
           </a:p>
           <a:p>
@@ -4481,7 +4481,7 @@
                 </a:solidFill>
                 <a:latin typeface="Arial"/>
               </a:rPr>
-              <a:t>Creator contest × Blockhub — creators bring players; distribution beyond us</a:t>
+              <a:t>61,900+ games, each a Celo tx  ·  2,000,000+ G$ paid to verified players</a:t>
             </a:r>
           </a:p>
           <a:p>
@@ -4509,7 +4509,7 @@
                 </a:solidFill>
                 <a:latin typeface="Arial"/>
               </a:rPr>
-              <a:t>Public payout ledger — every payout on-chain + public at /impact, tx-linked</a:t>
+              <a:t>21,385 G$ to the GoodDollar UBI pool  ·  zero bots paid  ·  all at /impact</a:t>
             </a:r>
           </a:p>
         </p:txBody>
@@ -4585,7 +4585,7 @@
                 </a:solidFill>
                 <a:latin typeface="Arial"/>
               </a:rPr>
-              <a:t>03 · PROOF OF IMPACT</a:t>
+              <a:t>03 · LIVE DEMO</a:t>
             </a:r>
           </a:p>
         </p:txBody>
@@ -4619,7 +4619,7 @@
                 </a:solidFill>
                 <a:latin typeface="Arial"/>
               </a:rPr>
-              <a:t>Real money to real humans</a:t>
+              <a:t>See it live</a:t>
             </a:r>
           </a:p>
         </p:txBody>
@@ -4670,7 +4670,7 @@
                 </a:solidFill>
                 <a:latin typeface="Arial"/>
               </a:rPr>
-              <a:t>875 players · 168 verified (19%) · 61,700+ games — every game a Celo tx</a:t>
+              <a:t>Tug of War — the live rope, two teams, 2,000,000 G$</a:t>
             </a:r>
           </a:p>
           <a:p>
@@ -4698,7 +4698,7 @@
                 </a:solidFill>
                 <a:latin typeface="Arial"/>
               </a:rPr>
-              <a:t>366,135 G$ + $50 USDC paid to verified players last cycle — on-chain, tx-linked</a:t>
+              <a:t>The recruiter board — every player recruits verified humans</a:t>
             </a:r>
           </a:p>
           <a:p>
@@ -4726,7 +4726,7 @@
                 </a:solidFill>
                 <a:latin typeface="Arial"/>
               </a:rPr>
-              <a:t>Over 2,000,000 G$ to players across all competitions — public at /impact</a:t>
+              <a:t>The impact page — every payout on-chain, each with its tx</a:t>
             </a:r>
           </a:p>
           <a:p>
@@ -4754,7 +4754,7 @@
                 </a:solidFill>
                 <a:latin typeface="Arial"/>
               </a:rPr>
-              <a:t>Tug of War live now: 2,000,000 G$ in prizes · 61 of 160 slots claimed</a:t>
+              <a:t>The Demo Day 1 → 6 growth curve</a:t>
             </a:r>
           </a:p>
           <a:p>
@@ -4782,7 +4782,7 @@
                 </a:solidFill>
                 <a:latin typeface="Arial"/>
               </a:rPr>
-              <a:t>21,385 G$ to UBI · every payout face-verification gated — zero bots paid</a:t>
+              <a:t>Zero bots — every score gated by GoodDollar face verification</a:t>
             </a:r>
           </a:p>
         </p:txBody>
@@ -4858,7 +4858,7 @@
                 </a:solidFill>
                 <a:latin typeface="Arial"/>
               </a:rPr>
-              <a:t>04 · MILESTONE PROGRESS</a:t>
+              <a:t>04 · BIGGEST GAME CHANGER</a:t>
             </a:r>
           </a:p>
         </p:txBody>
@@ -4892,7 +4892,7 @@
                 </a:solidFill>
                 <a:latin typeface="Arial"/>
               </a:rPr>
-              <a:t>What we set, what we shipped</a:t>
+              <a:t>Growth and verification became one motion</a:t>
             </a:r>
           </a:p>
         </p:txBody>
@@ -4943,7 +4943,7 @@
                 </a:solidFill>
                 <a:latin typeface="Arial"/>
               </a:rPr>
-              <a:t>Growth — 875 players, 168 verified vs 75, 61k tx vs 8k — exceeded</a:t>
+              <a:t>We stopped chasing signups</a:t>
             </a:r>
           </a:p>
           <a:p>
@@ -4971,7 +4971,7 @@
                 </a:solidFill>
                 <a:latin typeface="Arial"/>
               </a:rPr>
-              <a:t>G$ to players via competitions — over 2M vs 400k target — exceeded</a:t>
+              <a:t>We made every prize REQUIRE a verified human to earn it</a:t>
             </a:r>
           </a:p>
           <a:p>
@@ -4999,7 +4999,7 @@
                 </a:solidFill>
                 <a:latin typeface="Arial"/>
               </a:rPr>
-              <a:t>G$ to the GoodDollar UBI pool — 21,385 vs 2,500 — exceeded</a:t>
+              <a:t>So growth and verification stopped being two problems</a:t>
             </a:r>
           </a:p>
           <a:p>
@@ -5027,7 +5027,7 @@
                 </a:solidFill>
                 <a:latin typeface="Arial"/>
               </a:rPr>
-              <a:t>Public Dune / GoodDollar economy dashboard — 75%</a:t>
+              <a:t>Our biggest event markets proof-of-personhood, not the games</a:t>
             </a:r>
           </a:p>
           <a:p>
@@ -5055,7 +5055,7 @@
                 </a:solidFill>
                 <a:latin typeface="Arial"/>
               </a:rPr>
-              <a:t>Competition automation — standings automated; payout batching next</a:t>
+              <a:t>Result: the verified base rebuilt itself</a:t>
             </a:r>
           </a:p>
         </p:txBody>
@@ -5131,7 +5131,7 @@
                 </a:solidFill>
                 <a:latin typeface="Arial"/>
               </a:rPr>
-              <a:t>05 · WHAT BROKE</a:t>
+              <a:t>05 · GOODBUILDERS IMPACT</a:t>
             </a:r>
           </a:p>
         </p:txBody>
@@ -5165,7 +5165,7 @@
                 </a:solidFill>
                 <a:latin typeface="Arial"/>
               </a:rPr>
-              <a:t>The event froze — and we hardened it</a:t>
+              <a:t>What the program unlocked</a:t>
             </a:r>
           </a:p>
         </p:txBody>
@@ -5216,7 +5216,7 @@
                 </a:solidFill>
                 <a:latin typeface="Arial"/>
               </a:rPr>
-              <a:t>Our indexer hit a credit limit and paused — the Tug of War board froze ~16h</a:t>
+              <a:t>GoodDollar proof-of-personhood — the moat. "Zero bots paid" only exists because of it.</a:t>
             </a:r>
           </a:p>
           <a:p>
@@ -5244,7 +5244,7 @@
                 </a:solidFill>
                 <a:latin typeface="Arial"/>
               </a:rPr>
-              <a:t>Every game stayed on-chain; on resume all of it counted — no data lost</a:t>
+              <a:t>GoodDollar UBI routing — 20% of every spend back to real people</a:t>
             </a:r>
           </a:p>
           <a:p>
@@ -5272,7 +5272,7 @@
                 </a:solidFill>
                 <a:latin typeface="Arial"/>
               </a:rPr>
-              <a:t>We caught it and fixed it the same day</a:t>
+              <a:t>GoodAgents partnership — players deploy AI agents into the arena</a:t>
             </a:r>
           </a:p>
           <a:p>
@@ -5300,7 +5300,7 @@
                 </a:solidFill>
                 <a:latin typeface="Arial"/>
               </a:rPr>
-              <a:t>Next: billing safeguard + stall monitor so it never freezes silently again</a:t>
+              <a:t>Demo-day cadence + mentor — shipping discipline every two weeks</a:t>
             </a:r>
           </a:p>
         </p:txBody>
@@ -5376,7 +5376,7 @@
                 </a:solidFill>
                 <a:latin typeface="Arial"/>
               </a:rPr>
-              <a:t>06 · MILESTONES AHEAD</a:t>
+              <a:t>06 · WHAT’S NEXT</a:t>
             </a:r>
           </a:p>
         </p:txBody>
@@ -5410,7 +5410,7 @@
                 </a:solidFill>
                 <a:latin typeface="Arial"/>
               </a:rPr>
-              <a:t>Next</a:t>
+              <a:t>Past the season</a:t>
             </a:r>
           </a:p>
         </p:txBody>
@@ -5461,7 +5461,7 @@
                 </a:solidFill>
                 <a:latin typeface="Arial"/>
               </a:rPr>
-              <a:t>Finish the GoodDollar Dune dashboard — payouts-by-competition panel</a:t>
+              <a:t>GameArena games inside a partner chat app’s DMs — their users, our game, no leaving</a:t>
             </a:r>
           </a:p>
           <a:p>
@@ -5489,7 +5489,7 @@
                 </a:solidFill>
                 <a:latin typeface="Arial"/>
               </a:rPr>
-              <a:t>Full competition automation — scheduled sealing + payout batching</a:t>
+              <a:t>Verification retention — a re-verify system around the 3-day window</a:t>
             </a:r>
           </a:p>
           <a:p>
@@ -5517,7 +5517,7 @@
                 </a:solidFill>
                 <a:latin typeface="Arial"/>
               </a:rPr>
-              <a:t>Verification retention — re-verify nudges (3-day window is the ceiling)</a:t>
+              <a:t>The events engine to more partners — BlockHub creator contest is the first</a:t>
             </a:r>
           </a:p>
           <a:p>
@@ -5545,7 +5545,7 @@
                 </a:solidFill>
                 <a:latin typeface="Arial"/>
               </a:rPr>
-              <a:t>Roll the events engine to more partners — Blockhub is the first</a:t>
+              <a:t>MiniPay listing — GameArena in the pocket of the Global South</a:t>
             </a:r>
           </a:p>
         </p:txBody>
@@ -5621,7 +5621,7 @@
                 </a:solidFill>
                 <a:latin typeface="Arial"/>
               </a:rPr>
-              <a:t>07 · THE ASK</a:t>
+              <a:t>THANK YOU</a:t>
             </a:r>
           </a:p>
         </p:txBody>
@@ -5655,7 +5655,7 @@
                 </a:solidFill>
                 <a:latin typeface="Arial"/>
               </a:rPr>
-              <a:t>Two asks</a:t>
+              <a:t>Watch this one</a:t>
             </a:r>
           </a:p>
         </p:txBody>
@@ -5706,7 +5706,7 @@
                 </a:solidFill>
                 <a:latin typeface="Arial"/>
               </a:rPr>
-              <a:t>Intros to creator communities / partners to run contests (like Blockhub)</a:t>
+              <a:t>Play + verify + compete → gamearenahq.xyz</a:t>
             </a:r>
           </a:p>
           <a:p>
@@ -5734,7 +5734,7 @@
                 </a:solidFill>
                 <a:latin typeface="Arial"/>
               </a:rPr>
-              <a:t>A direct line to GoodCollective to formalize our UBI routing</a:t>
+              <a:t>Every number, on-chain → gamearenahq.xyz/impact  ·  dune.com/ogazboiz/gamearena</a:t>
             </a:r>
           </a:p>
         </p:txBody>

</xml_diff>

<commit_message>
DD6 deck: ground the opening in GameArena's real origin (reset + rewards that reach real people)
</commit_message>
<xml_diff>
--- a/marketing/demo-day-6-deck.pptx
+++ b/marketing/demo-day-6-deck.pptx
@@ -4059,7 +4059,7 @@
                 </a:solidFill>
                 <a:latin typeface="Arial"/>
               </a:rPr>
-              <a:t>Quick skill games. Real G$. Real humans — never bots.</a:t>
+              <a:t>Quick skill games that make you sharper. Verified humans, no bots, real G$ every day.</a:t>
             </a:r>
           </a:p>
           <a:p>
@@ -4185,7 +4185,7 @@
                 </a:solidFill>
                 <a:latin typeface="Arial"/>
               </a:rPr>
-              <a:t>Play-to-earn pays bots, not people</a:t>
+              <a:t>Why we built it</a:t>
             </a:r>
           </a:p>
         </p:txBody>
@@ -4236,7 +4236,7 @@
                 </a:solidFill>
                 <a:latin typeface="Arial"/>
               </a:rPr>
-              <a:t>Every reward game gets farmed by scripts and spare wallets — the pool drains to no one real</a:t>
+              <a:t>Two problems: scrolling leaves you worse, and web3 rewards never reached real people — wallet, gas, then bots farm the pool</a:t>
             </a:r>
           </a:p>
           <a:p>
@@ -4264,7 +4264,7 @@
                 </a:solidFill>
                 <a:latin typeface="Arial"/>
               </a:rPr>
-              <a:t>Our bet: gate every game and prize on GoodDollar proof-of-personhood. Zero bots ever paid.</a:t>
+              <a:t>Our answer: 30-second skill games that sharpen you — Google sign-in, zero gas, every player a verified human earning real G$ daily</a:t>
             </a:r>
           </a:p>
         </p:txBody>

</xml_diff>

<commit_message>
DD6 deck: align metrics with Flow State milestones (targets beaten) + Month 3 next steps
</commit_message>
<xml_diff>
--- a/marketing/demo-day-6-deck.pptx
+++ b/marketing/demo-day-6-deck.pptx
@@ -4374,7 +4374,7 @@
                 </a:solidFill>
                 <a:latin typeface="Arial"/>
               </a:rPr>
-              <a:t>Growth, all on-chain</a:t>
+              <a:t>Every target beaten — all on-chain</a:t>
             </a:r>
           </a:p>
         </p:txBody>
@@ -4425,7 +4425,7 @@
                 </a:solidFill>
                 <a:latin typeface="Arial"/>
               </a:rPr>
-              <a:t>227 — 879 players across the season</a:t>
+              <a:t>479 GamePass wallets (target 200, 2.4×)  ·  44 paying wallets (target 30)</a:t>
             </a:r>
           </a:p>
           <a:p>
@@ -4453,7 +4453,7 @@
                 </a:solidFill>
                 <a:latin typeface="Arial"/>
               </a:rPr>
-              <a:t>163 verified humans (19%) — rebuilt from a lapsed base</a:t>
+              <a:t>163 verified humans  ·  7,355 on-chain transactions in 30 days (target 1,500, ~5×)</a:t>
             </a:r>
           </a:p>
           <a:p>
@@ -4481,7 +4481,7 @@
                 </a:solidFill>
                 <a:latin typeface="Arial"/>
               </a:rPr>
-              <a:t>61,900+ games, each a Celo tx  ·  2,000,000+ G$ paid to verified players</a:t>
+              <a:t>9,222 G$ in perk purchases (1,768 buys)  ·  12,229 G$ to the GoodDollar UBI pool (target 2,500)</a:t>
             </a:r>
           </a:p>
           <a:p>
@@ -4509,7 +4509,7 @@
                 </a:solidFill>
                 <a:latin typeface="Arial"/>
               </a:rPr>
-              <a:t>21,385 G$ to the GoodDollar UBI pool  ·  zero bots paid  ·  all at /impact</a:t>
+              <a:t>2,000,000+ G$ paid to verified players — season target 400K, 5×  ·  all at /impact</a:t>
             </a:r>
           </a:p>
         </p:txBody>
@@ -4999,7 +4999,7 @@
                 </a:solidFill>
                 <a:latin typeface="Arial"/>
               </a:rPr>
-              <a:t>So growth and verification stopped being two problems</a:t>
+              <a:t>Growth and verification stopped being two problems — one motion</a:t>
             </a:r>
           </a:p>
           <a:p>
@@ -5027,7 +5027,7 @@
                 </a:solidFill>
                 <a:latin typeface="Arial"/>
               </a:rPr>
-              <a:t>Our biggest event markets proof-of-personhood, not the games</a:t>
+              <a:t>Then we made it provable: removed 896 sybil matches, gated ranking on a GamePass</a:t>
             </a:r>
           </a:p>
           <a:p>
@@ -5055,7 +5055,7 @@
                 </a:solidFill>
                 <a:latin typeface="Arial"/>
               </a:rPr>
-              <a:t>Result: the verified base rebuilt itself</a:t>
+              <a:t>So the traction is provably real people, not inflation</a:t>
             </a:r>
           </a:p>
         </p:txBody>
@@ -5410,7 +5410,7 @@
                 </a:solidFill>
                 <a:latin typeface="Arial"/>
               </a:rPr>
-              <a:t>Past the season</a:t>
+              <a:t>The rails are built — next is scale</a:t>
             </a:r>
           </a:p>
         </p:txBody>
@@ -5461,7 +5461,7 @@
                 </a:solidFill>
                 <a:latin typeface="Arial"/>
               </a:rPr>
-              <a:t>GameArena games inside a partner chat app’s DMs — their users, our game, no leaving</a:t>
+              <a:t>Shipped: friend duels (stake G$, winner takes 80%, 20% to UBI)  ·  voice MARKOV</a:t>
             </a:r>
           </a:p>
           <a:p>
@@ -5489,7 +5489,7 @@
                 </a:solidFill>
                 <a:latin typeface="Arial"/>
               </a:rPr>
-              <a:t>Verification retention — a re-verify system around the 3-day window</a:t>
+              <a:t>Month 3 targets: 200 wallets  ·  75 verified humans  ·  30 duels  ·  5 GoodCollectives</a:t>
             </a:r>
           </a:p>
           <a:p>
@@ -5517,7 +5517,7 @@
                 </a:solidFill>
                 <a:latin typeface="Arial"/>
               </a:rPr>
-              <a:t>The events engine to more partners — BlockHub creator contest is the first</a:t>
+              <a:t>GameArena games inside a partner chat app’s DMs — their users, our game, no leaving</a:t>
             </a:r>
           </a:p>
           <a:p>

</xml_diff>

<commit_message>
DD6 deck: ground every metric in live on-chain data (2026-09-29), add Demo Day 1 to now growth arc
</commit_message>
<xml_diff>
--- a/marketing/demo-day-6-deck.pptx
+++ b/marketing/demo-day-6-deck.pptx
@@ -4264,7 +4264,7 @@
                 </a:solidFill>
                 <a:latin typeface="Arial"/>
               </a:rPr>
-              <a:t>Our answer: 30-second skill games that sharpen you — Google sign-in, zero gas, every player a verified human earning real G$ daily</a:t>
+              <a:t>Our answer: 30-second skill games — Google sign-in, zero gas, every player a verified human earning real G$ daily.  Demo Day 1: 227 players, 385 G$ to UBI</a:t>
             </a:r>
           </a:p>
         </p:txBody>
@@ -4374,7 +4374,7 @@
                 </a:solidFill>
                 <a:latin typeface="Arial"/>
               </a:rPr>
-              <a:t>Every target beaten — all on-chain</a:t>
+              <a:t>Demo Day 1 → now  ·  every number on-chain</a:t>
             </a:r>
           </a:p>
         </p:txBody>
@@ -4425,7 +4425,7 @@
                 </a:solidFill>
                 <a:latin typeface="Arial"/>
               </a:rPr>
-              <a:t>479 GamePass wallets (target 200, 2.4×)  ·  44 paying wallets (target 30)</a:t>
+              <a:t>Players: 227 → 879 (3.9×)  ·  163 verified humans</a:t>
             </a:r>
           </a:p>
           <a:p>
@@ -4453,7 +4453,7 @@
                 </a:solidFill>
                 <a:latin typeface="Arial"/>
               </a:rPr>
-              <a:t>163 verified humans  ·  7,355 on-chain transactions in 30 days (target 1,500, ~5×)</a:t>
+              <a:t>Games: 12,483 → 61,966 (5×) — each a Celo transaction</a:t>
             </a:r>
           </a:p>
           <a:p>
@@ -4481,7 +4481,7 @@
                 </a:solidFill>
                 <a:latin typeface="Arial"/>
               </a:rPr>
-              <a:t>9,222 G$ in perk purchases (1,768 buys)  ·  12,229 G$ to the GoodDollar UBI pool (target 2,500)</a:t>
+              <a:t>G$ to UBI pool: 385 → 45,769 (119×)  ·  121,922 G$ perk spend / 3,422 buys</a:t>
             </a:r>
           </a:p>
           <a:p>
@@ -4509,7 +4509,7 @@
                 </a:solidFill>
                 <a:latin typeface="Arial"/>
               </a:rPr>
-              <a:t>2,000,000+ G$ paid to verified players — season target 400K, 5×  ·  all at /impact</a:t>
+              <a:t>2,106,455 G$ + $50 USDC to verified players — target 400K, 5×  ·  all at /impact</a:t>
             </a:r>
           </a:p>
         </p:txBody>

</xml_diff>